<commit_message>
POA closure updates User Story instead of separate doc, remove failing .github/roles tests, update PPTX
</commit_message>
<xml_diff>
--- a/Golazo-Copilotv2/WorkItems/Golazo-Copilot-Overview.pptx
+++ b/Golazo-Copilotv2/WorkItems/Golazo-Copilot-Overview.pptx
@@ -3326,7 +3326,7 @@
               </a:defRPr>
             </a:pPr>
             <a:r>
-              <a:t>v2.104  •  Python  •  MCP Protocol  •  MIT License</a:t>
+              <a:t>v2.105  •  Python  •  MCP Protocol  •  MIT License</a:t>
             </a:r>
           </a:p>
         </p:txBody>
@@ -3761,8 +3761,8 @@
         </p:nvSpPr>
         <p:spPr>
           <a:xfrm>
-            <a:off x="457200" y="1188720"/>
-            <a:ext cx="4114800" cy="365760"/>
+            <a:off x="274320" y="1188720"/>
+            <a:ext cx="4074972" cy="365760"/>
           </a:xfrm>
           <a:prstGeom prst="rect">
             <a:avLst/>
@@ -3797,8 +3797,8 @@
         </p:nvSpPr>
         <p:spPr>
           <a:xfrm>
-            <a:off x="457200" y="1508760"/>
-            <a:ext cx="4114800" cy="27432"/>
+            <a:off x="274320" y="1508760"/>
+            <a:ext cx="4074972" cy="27432"/>
           </a:xfrm>
           <a:prstGeom prst="rect">
             <a:avLst/>
@@ -3840,8 +3840,8 @@
         </p:nvSpPr>
         <p:spPr>
           <a:xfrm>
-            <a:off x="4572000" y="1188720"/>
-            <a:ext cx="2011680" cy="365760"/>
+            <a:off x="4503292" y="1188720"/>
+            <a:ext cx="1960486" cy="365760"/>
           </a:xfrm>
           <a:prstGeom prst="rect">
             <a:avLst/>
@@ -3876,8 +3876,8 @@
         </p:nvSpPr>
         <p:spPr>
           <a:xfrm>
-            <a:off x="4572000" y="1508760"/>
-            <a:ext cx="2011680" cy="27432"/>
+            <a:off x="4503292" y="1508760"/>
+            <a:ext cx="1960486" cy="27432"/>
           </a:xfrm>
           <a:prstGeom prst="rect">
             <a:avLst/>
@@ -3919,8 +3919,8 @@
         </p:nvSpPr>
         <p:spPr>
           <a:xfrm>
-            <a:off x="6675120" y="1188720"/>
-            <a:ext cx="3017520" cy="365760"/>
+            <a:off x="6617778" y="1188720"/>
+            <a:ext cx="5132215" cy="365760"/>
           </a:xfrm>
           <a:prstGeom prst="rect">
             <a:avLst/>
@@ -3955,8 +3955,8 @@
         </p:nvSpPr>
         <p:spPr>
           <a:xfrm>
-            <a:off x="6675120" y="1508760"/>
-            <a:ext cx="3017520" cy="27432"/>
+            <a:off x="6617778" y="1508760"/>
+            <a:ext cx="5132215" cy="27432"/>
           </a:xfrm>
           <a:prstGeom prst="rect">
             <a:avLst/>
@@ -3992,14 +3992,139 @@
       </p:sp>
       <p:sp>
         <p:nvSpPr>
-          <p:cNvPr id="10" name="Rounded Rectangle 9"/>
+          <p:cNvPr id="27" name="TextBox 26"/>
+          <p:cNvSpPr txBox="1"/>
+          <p:nvPr/>
+        </p:nvSpPr>
+        <p:spPr>
+          <a:xfrm>
+            <a:off x="731520" y="3200400"/>
+            <a:ext cx="8229600" cy="2286000"/>
+          </a:xfrm>
+          <a:prstGeom prst="rect">
+            <a:avLst/>
+          </a:prstGeom>
+          <a:noFill/>
+        </p:spPr>
+        <p:txBody>
+          <a:bodyPr wrap="square">
+            <a:spAutoFit/>
+          </a:bodyPr>
+          <a:lstStyle/>
+          <a:p>
+            <a:pPr>
+              <a:spcAft>
+                <a:spcPts val="600"/>
+              </a:spcAft>
+              <a:defRPr sz="1200">
+                <a:solidFill>
+                  <a:srgbClr val="333333"/>
+                </a:solidFill>
+                <a:latin typeface="Segoe UI"/>
+              </a:defRPr>
+            </a:pPr>
+            <a:r>
+              <a:rPr sz="1100"/>
+              <a:t>Forward transitions are validated — you cannot skip roles</a:t>
+            </a:r>
+          </a:p>
+          <a:p>
+            <a:pPr>
+              <a:spcAft>
+                <a:spcPts val="600"/>
+              </a:spcAft>
+              <a:defRPr sz="1200">
+                <a:solidFill>
+                  <a:srgbClr val="333333"/>
+                </a:solidFill>
+                <a:latin typeface="Segoe UI"/>
+              </a:defRPr>
+            </a:pPr>
+            <a:r>
+              <a:rPr lang="en-US" sz="1100"/>
+              <a:t>Backward transitions to any prior role are always allowed</a:t>
+            </a:r>
+          </a:p>
+          <a:p>
+            <a:pPr>
+              <a:spcAft>
+                <a:spcPts val="600"/>
+              </a:spcAft>
+              <a:defRPr sz="1200">
+                <a:solidFill>
+                  <a:srgbClr val="333333"/>
+                </a:solidFill>
+                <a:latin typeface="Segoe UI"/>
+              </a:defRPr>
+            </a:pPr>
+            <a:r>
+              <a:rPr lang="en-US" sz="1100"/>
+              <a:t>Retrospective can transition back to POA for formal closure</a:t>
+            </a:r>
+          </a:p>
+          <a:p>
+            <a:pPr>
+              <a:spcAft>
+                <a:spcPts val="600"/>
+              </a:spcAft>
+              <a:defRPr sz="1200">
+                <a:solidFill>
+                  <a:srgbClr val="333333"/>
+                </a:solidFill>
+                <a:latin typeface="Segoe UI"/>
+              </a:defRPr>
+            </a:pPr>
+            <a:r>
+              <a:rPr lang="en-US" sz="1100"/>
+              <a:t>Each role defines Required Outputs that must exist before moving forward</a:t>
+            </a:r>
+          </a:p>
+          <a:p>
+            <a:pPr>
+              <a:spcAft>
+                <a:spcPts val="600"/>
+              </a:spcAft>
+              <a:defRPr sz="1200">
+                <a:solidFill>
+                  <a:srgbClr val="333333"/>
+                </a:solidFill>
+                <a:latin typeface="Segoe UI"/>
+              </a:defRPr>
+            </a:pPr>
+            <a:r>
+              <a:rPr lang="en-US" sz="1100"/>
+              <a:t>Role Decision Notes are required for every role (audit trail)</a:t>
+            </a:r>
+          </a:p>
+          <a:p>
+            <a:pPr>
+              <a:spcAft>
+                <a:spcPts val="600"/>
+              </a:spcAft>
+              <a:defRPr sz="1200">
+                <a:solidFill>
+                  <a:srgbClr val="333333"/>
+                </a:solidFill>
+                <a:latin typeface="Segoe UI"/>
+              </a:defRPr>
+            </a:pPr>
+            <a:r>
+              <a:rPr lang="en-US" sz="1100"/>
+              <a:t>Gates can be bypassed with explicit consent (recorded as deviations)</a:t>
+            </a:r>
+          </a:p>
+        </p:txBody>
+      </p:sp>
+      <p:sp>
+        <p:nvSpPr>
+          <p:cNvPr id="28" name="Rounded Rectangle 27"/>
           <p:cNvSpPr/>
           <p:nvPr/>
         </p:nvSpPr>
         <p:spPr>
           <a:xfrm>
-            <a:off x="457200" y="1920240"/>
-            <a:ext cx="1051560" cy="777240"/>
+            <a:off x="274320" y="1920240"/>
+            <a:ext cx="903243" cy="731520"/>
           </a:xfrm>
           <a:prstGeom prst="roundRect">
             <a:avLst/>
@@ -4029,25 +4154,22 @@
           <a:bodyPr rtlCol="0" anchor="ctr" wrap="square"/>
           <a:lstStyle/>
           <a:p>
-            <a:pPr algn="ctr">
-              <a:spcBef>
-                <a:spcPts val="0"/>
-              </a:spcBef>
-              <a:spcAft>
-                <a:spcPts val="0"/>
-              </a:spcAft>
-              <a:defRPr sz="1000" b="1">
+            <a:pPr algn="ctr"/>
+            <a:r>
+              <a:rPr sz="1000">
                 <a:solidFill>
                   <a:srgbClr val="FFFFFF"/>
                 </a:solidFill>
-                <a:latin typeface="Segoe UI"/>
-              </a:defRPr>
-            </a:pPr>
-            <a:r>
+              </a:rPr>
               <a:t>Project</a:t>
             </a:r>
             <a:br/>
             <a:r>
+              <a:rPr sz="1000">
+                <a:solidFill>
+                  <a:srgbClr val="FFFFFF"/>
+                </a:solidFill>
+              </a:rPr>
               <a:t>Owner</a:t>
             </a:r>
           </a:p>
@@ -4055,20 +4177,20 @@
       </p:sp>
       <p:sp>
         <p:nvSpPr>
-          <p:cNvPr id="11" name="Right Arrow 10"/>
+          <p:cNvPr id="29" name="Right Arrow 28"/>
           <p:cNvSpPr/>
           <p:nvPr/>
         </p:nvSpPr>
         <p:spPr>
           <a:xfrm>
-            <a:off x="1508760" y="2171700"/>
-            <a:ext cx="146304" cy="274320"/>
+            <a:off x="1195563" y="2171700"/>
+            <a:ext cx="118000" cy="228600"/>
           </a:xfrm>
           <a:prstGeom prst="rightArrow">
             <a:avLst/>
           </a:prstGeom>
           <a:solidFill>
-            <a:srgbClr val="666666"/>
+            <a:srgbClr val="808080"/>
           </a:solidFill>
           <a:ln>
             <a:noFill/>
@@ -4098,14 +4220,14 @@
       </p:sp>
       <p:sp>
         <p:nvSpPr>
-          <p:cNvPr id="12" name="Rounded Rectangle 11"/>
+          <p:cNvPr id="30" name="Rounded Rectangle 29"/>
           <p:cNvSpPr/>
           <p:nvPr/>
         </p:nvSpPr>
         <p:spPr>
           <a:xfrm>
-            <a:off x="1655064" y="1920240"/>
-            <a:ext cx="1051560" cy="777240"/>
+            <a:off x="1331563" y="1920240"/>
+            <a:ext cx="903243" cy="731520"/>
           </a:xfrm>
           <a:prstGeom prst="roundRect">
             <a:avLst/>
@@ -4135,25 +4257,22 @@
           <a:bodyPr rtlCol="0" anchor="ctr" wrap="square"/>
           <a:lstStyle/>
           <a:p>
-            <a:pPr algn="ctr">
-              <a:spcBef>
-                <a:spcPts val="0"/>
-              </a:spcBef>
-              <a:spcAft>
-                <a:spcPts val="0"/>
-              </a:spcAft>
-              <a:defRPr sz="1000" b="1">
+            <a:pPr algn="ctr"/>
+            <a:r>
+              <a:rPr sz="1000">
                 <a:solidFill>
                   <a:srgbClr val="FFFFFF"/>
                 </a:solidFill>
-                <a:latin typeface="Segoe UI"/>
-              </a:defRPr>
-            </a:pPr>
-            <a:r>
+              </a:rPr>
               <a:t>Program</a:t>
             </a:r>
             <a:br/>
             <a:r>
+              <a:rPr sz="1000">
+                <a:solidFill>
+                  <a:srgbClr val="FFFFFF"/>
+                </a:solidFill>
+              </a:rPr>
               <a:t>Manager</a:t>
             </a:r>
           </a:p>
@@ -4161,20 +4280,20 @@
       </p:sp>
       <p:sp>
         <p:nvSpPr>
-          <p:cNvPr id="13" name="Right Arrow 12"/>
+          <p:cNvPr id="31" name="Right Arrow 30"/>
           <p:cNvSpPr/>
           <p:nvPr/>
         </p:nvSpPr>
         <p:spPr>
           <a:xfrm>
-            <a:off x="2706624" y="2171700"/>
-            <a:ext cx="146304" cy="274320"/>
+            <a:off x="2252806" y="2171700"/>
+            <a:ext cx="118000" cy="228600"/>
           </a:xfrm>
           <a:prstGeom prst="rightArrow">
             <a:avLst/>
           </a:prstGeom>
           <a:solidFill>
-            <a:srgbClr val="666666"/>
+            <a:srgbClr val="808080"/>
           </a:solidFill>
           <a:ln>
             <a:noFill/>
@@ -4204,14 +4323,14 @@
       </p:sp>
       <p:sp>
         <p:nvSpPr>
-          <p:cNvPr id="14" name="Rounded Rectangle 13"/>
+          <p:cNvPr id="32" name="Rounded Rectangle 31"/>
           <p:cNvSpPr/>
           <p:nvPr/>
         </p:nvSpPr>
         <p:spPr>
           <a:xfrm>
-            <a:off x="2852928" y="1920240"/>
-            <a:ext cx="1051560" cy="777240"/>
+            <a:off x="2388806" y="1920240"/>
+            <a:ext cx="903243" cy="731520"/>
           </a:xfrm>
           <a:prstGeom prst="roundRect">
             <a:avLst/>
@@ -4241,25 +4360,22 @@
           <a:bodyPr rtlCol="0" anchor="ctr" wrap="square"/>
           <a:lstStyle/>
           <a:p>
-            <a:pPr algn="ctr">
-              <a:spcBef>
-                <a:spcPts val="0"/>
-              </a:spcBef>
-              <a:spcAft>
-                <a:spcPts val="0"/>
-              </a:spcAft>
-              <a:defRPr sz="1000" b="1">
+            <a:pPr algn="ctr"/>
+            <a:r>
+              <a:rPr sz="1000">
                 <a:solidFill>
                   <a:srgbClr val="FFFFFF"/>
                 </a:solidFill>
-                <a:latin typeface="Segoe UI"/>
-              </a:defRPr>
-            </a:pPr>
-            <a:r>
+              </a:rPr>
               <a:t>Quality</a:t>
             </a:r>
             <a:br/>
             <a:r>
+              <a:rPr sz="1000">
+                <a:solidFill>
+                  <a:srgbClr val="FFFFFF"/>
+                </a:solidFill>
+              </a:rPr>
               <a:t>Assurance</a:t>
             </a:r>
           </a:p>
@@ -4267,20 +4383,20 @@
       </p:sp>
       <p:sp>
         <p:nvSpPr>
-          <p:cNvPr id="15" name="Right Arrow 14"/>
+          <p:cNvPr id="33" name="Right Arrow 32"/>
           <p:cNvSpPr/>
           <p:nvPr/>
         </p:nvSpPr>
         <p:spPr>
           <a:xfrm>
-            <a:off x="3904488" y="2171700"/>
-            <a:ext cx="146304" cy="274320"/>
+            <a:off x="3310049" y="2171700"/>
+            <a:ext cx="118000" cy="228600"/>
           </a:xfrm>
           <a:prstGeom prst="rightArrow">
             <a:avLst/>
           </a:prstGeom>
           <a:solidFill>
-            <a:srgbClr val="666666"/>
+            <a:srgbClr val="808080"/>
           </a:solidFill>
           <a:ln>
             <a:noFill/>
@@ -4310,14 +4426,14 @@
       </p:sp>
       <p:sp>
         <p:nvSpPr>
-          <p:cNvPr id="16" name="Rounded Rectangle 15"/>
+          <p:cNvPr id="34" name="Rounded Rectangle 33"/>
           <p:cNvSpPr/>
           <p:nvPr/>
         </p:nvSpPr>
         <p:spPr>
           <a:xfrm>
-            <a:off x="4050792" y="1920240"/>
-            <a:ext cx="1051560" cy="777240"/>
+            <a:off x="3446049" y="1920240"/>
+            <a:ext cx="903243" cy="731520"/>
           </a:xfrm>
           <a:prstGeom prst="roundRect">
             <a:avLst/>
@@ -4347,21 +4463,13 @@
           <a:bodyPr rtlCol="0" anchor="ctr" wrap="square"/>
           <a:lstStyle/>
           <a:p>
-            <a:pPr algn="ctr">
-              <a:spcBef>
-                <a:spcPts val="0"/>
-              </a:spcBef>
-              <a:spcAft>
-                <a:spcPts val="0"/>
-              </a:spcAft>
-              <a:defRPr sz="1000" b="1">
+            <a:pPr algn="ctr"/>
+            <a:r>
+              <a:rPr sz="1000">
                 <a:solidFill>
                   <a:srgbClr val="FFFFFF"/>
                 </a:solidFill>
-                <a:latin typeface="Segoe UI"/>
-              </a:defRPr>
-            </a:pPr>
-            <a:r>
+              </a:rPr>
               <a:t>Architect</a:t>
             </a:r>
           </a:p>
@@ -4369,20 +4477,20 @@
       </p:sp>
       <p:sp>
         <p:nvSpPr>
-          <p:cNvPr id="17" name="Right Arrow 16"/>
+          <p:cNvPr id="35" name="Right Arrow 34"/>
           <p:cNvSpPr/>
           <p:nvPr/>
         </p:nvSpPr>
         <p:spPr>
           <a:xfrm>
-            <a:off x="5102352" y="2171700"/>
-            <a:ext cx="146304" cy="274320"/>
+            <a:off x="4367292" y="2171700"/>
+            <a:ext cx="118000" cy="228600"/>
           </a:xfrm>
           <a:prstGeom prst="rightArrow">
             <a:avLst/>
           </a:prstGeom>
           <a:solidFill>
-            <a:srgbClr val="666666"/>
+            <a:srgbClr val="808080"/>
           </a:solidFill>
           <a:ln>
             <a:noFill/>
@@ -4412,14 +4520,117 @@
       </p:sp>
       <p:sp>
         <p:nvSpPr>
-          <p:cNvPr id="18" name="Rounded Rectangle 17"/>
+          <p:cNvPr id="36" name="Rounded Rectangle 35"/>
           <p:cNvSpPr/>
           <p:nvPr/>
         </p:nvSpPr>
         <p:spPr>
           <a:xfrm>
-            <a:off x="5248656" y="1920240"/>
-            <a:ext cx="1051560" cy="777240"/>
+            <a:off x="4503292" y="1920240"/>
+            <a:ext cx="903243" cy="731520"/>
+          </a:xfrm>
+          <a:prstGeom prst="roundRect">
+            <a:avLst/>
+          </a:prstGeom>
+          <a:solidFill>
+            <a:srgbClr val="008044"/>
+          </a:solidFill>
+          <a:ln>
+            <a:noFill/>
+          </a:ln>
+        </p:spPr>
+        <p:style>
+          <a:lnRef idx="1">
+            <a:schemeClr val="accent1"/>
+          </a:lnRef>
+          <a:fillRef idx="3">
+            <a:schemeClr val="accent1"/>
+          </a:fillRef>
+          <a:effectRef idx="2">
+            <a:schemeClr val="accent1"/>
+          </a:effectRef>
+          <a:fontRef idx="minor">
+            <a:schemeClr val="lt1"/>
+          </a:fontRef>
+        </p:style>
+        <p:txBody>
+          <a:bodyPr rtlCol="0" anchor="ctr" wrap="square"/>
+          <a:lstStyle/>
+          <a:p>
+            <a:pPr algn="ctr"/>
+            <a:r>
+              <a:rPr sz="1000">
+                <a:solidFill>
+                  <a:srgbClr val="FFFFFF"/>
+                </a:solidFill>
+              </a:rPr>
+              <a:t>Domain</a:t>
+            </a:r>
+            <a:br/>
+            <a:r>
+              <a:rPr sz="1000">
+                <a:solidFill>
+                  <a:srgbClr val="FFFFFF"/>
+                </a:solidFill>
+              </a:rPr>
+              <a:t>Expert</a:t>
+            </a:r>
+          </a:p>
+        </p:txBody>
+      </p:sp>
+      <p:sp>
+        <p:nvSpPr>
+          <p:cNvPr id="37" name="Right Arrow 36"/>
+          <p:cNvSpPr/>
+          <p:nvPr/>
+        </p:nvSpPr>
+        <p:spPr>
+          <a:xfrm>
+            <a:off x="5424535" y="2171700"/>
+            <a:ext cx="118000" cy="228600"/>
+          </a:xfrm>
+          <a:prstGeom prst="rightArrow">
+            <a:avLst/>
+          </a:prstGeom>
+          <a:solidFill>
+            <a:srgbClr val="808080"/>
+          </a:solidFill>
+          <a:ln>
+            <a:noFill/>
+          </a:ln>
+        </p:spPr>
+        <p:style>
+          <a:lnRef idx="1">
+            <a:schemeClr val="accent1"/>
+          </a:lnRef>
+          <a:fillRef idx="3">
+            <a:schemeClr val="accent1"/>
+          </a:fillRef>
+          <a:effectRef idx="2">
+            <a:schemeClr val="accent1"/>
+          </a:effectRef>
+          <a:fontRef idx="minor">
+            <a:schemeClr val="lt1"/>
+          </a:fontRef>
+        </p:style>
+        <p:txBody>
+          <a:bodyPr rtlCol="0" anchor="ctr"/>
+          <a:lstStyle/>
+          <a:p>
+            <a:pPr algn="ctr"/>
+          </a:p>
+        </p:txBody>
+      </p:sp>
+      <p:sp>
+        <p:nvSpPr>
+          <p:cNvPr id="38" name="Rounded Rectangle 37"/>
+          <p:cNvSpPr/>
+          <p:nvPr/>
+        </p:nvSpPr>
+        <p:spPr>
+          <a:xfrm>
+            <a:off x="5560535" y="1920240"/>
+            <a:ext cx="903243" cy="731520"/>
           </a:xfrm>
           <a:prstGeom prst="roundRect">
             <a:avLst/>
@@ -4449,21 +4660,13 @@
           <a:bodyPr rtlCol="0" anchor="ctr" wrap="square"/>
           <a:lstStyle/>
           <a:p>
-            <a:pPr algn="ctr">
-              <a:spcBef>
-                <a:spcPts val="0"/>
-              </a:spcBef>
-              <a:spcAft>
-                <a:spcPts val="0"/>
-              </a:spcAft>
-              <a:defRPr sz="1000" b="1">
+            <a:pPr algn="ctr"/>
+            <a:r>
+              <a:rPr sz="1000">
                 <a:solidFill>
                   <a:srgbClr val="FFFFFF"/>
                 </a:solidFill>
-                <a:latin typeface="Segoe UI"/>
-              </a:defRPr>
-            </a:pPr>
-            <a:r>
+              </a:rPr>
               <a:t>Developer</a:t>
             </a:r>
           </a:p>
@@ -4471,20 +4674,20 @@
       </p:sp>
       <p:sp>
         <p:nvSpPr>
-          <p:cNvPr id="19" name="Right Arrow 18"/>
+          <p:cNvPr id="39" name="Right Arrow 38"/>
           <p:cNvSpPr/>
           <p:nvPr/>
         </p:nvSpPr>
         <p:spPr>
           <a:xfrm>
-            <a:off x="6300216" y="2171700"/>
-            <a:ext cx="146304" cy="274320"/>
+            <a:off x="6481778" y="2171700"/>
+            <a:ext cx="118000" cy="228600"/>
           </a:xfrm>
           <a:prstGeom prst="rightArrow">
             <a:avLst/>
           </a:prstGeom>
           <a:solidFill>
-            <a:srgbClr val="666666"/>
+            <a:srgbClr val="808080"/>
           </a:solidFill>
           <a:ln>
             <a:noFill/>
@@ -4514,14 +4717,14 @@
       </p:sp>
       <p:sp>
         <p:nvSpPr>
-          <p:cNvPr id="20" name="Rounded Rectangle 19"/>
+          <p:cNvPr id="40" name="Rounded Rectangle 39"/>
           <p:cNvSpPr/>
           <p:nvPr/>
         </p:nvSpPr>
         <p:spPr>
           <a:xfrm>
-            <a:off x="6446520" y="1920240"/>
-            <a:ext cx="1051560" cy="777240"/>
+            <a:off x="6617778" y="1920240"/>
+            <a:ext cx="903243" cy="731520"/>
           </a:xfrm>
           <a:prstGeom prst="roundRect">
             <a:avLst/>
@@ -4551,25 +4754,22 @@
           <a:bodyPr rtlCol="0" anchor="ctr" wrap="square"/>
           <a:lstStyle/>
           <a:p>
-            <a:pPr algn="ctr">
-              <a:spcBef>
-                <a:spcPts val="0"/>
-              </a:spcBef>
-              <a:spcAft>
-                <a:spcPts val="0"/>
-              </a:spcAft>
-              <a:defRPr sz="1000" b="1">
+            <a:pPr algn="ctr"/>
+            <a:r>
+              <a:rPr sz="1000">
                 <a:solidFill>
                   <a:srgbClr val="FFFFFF"/>
                 </a:solidFill>
-                <a:latin typeface="Segoe UI"/>
-              </a:defRPr>
-            </a:pPr>
-            <a:r>
+              </a:rPr>
               <a:t>Refactor</a:t>
             </a:r>
             <a:br/>
             <a:r>
+              <a:rPr sz="1000">
+                <a:solidFill>
+                  <a:srgbClr val="FFFFFF"/>
+                </a:solidFill>
+              </a:rPr>
               <a:t>Expert</a:t>
             </a:r>
           </a:p>
@@ -4577,20 +4777,20 @@
       </p:sp>
       <p:sp>
         <p:nvSpPr>
-          <p:cNvPr id="21" name="Right Arrow 20"/>
+          <p:cNvPr id="41" name="Right Arrow 40"/>
           <p:cNvSpPr/>
           <p:nvPr/>
         </p:nvSpPr>
         <p:spPr>
           <a:xfrm>
-            <a:off x="7498080" y="2171700"/>
-            <a:ext cx="146304" cy="274320"/>
+            <a:off x="7539021" y="2171700"/>
+            <a:ext cx="118000" cy="228600"/>
           </a:xfrm>
           <a:prstGeom prst="rightArrow">
             <a:avLst/>
           </a:prstGeom>
           <a:solidFill>
-            <a:srgbClr val="666666"/>
+            <a:srgbClr val="808080"/>
           </a:solidFill>
           <a:ln>
             <a:noFill/>
@@ -4620,14 +4820,14 @@
       </p:sp>
       <p:sp>
         <p:nvSpPr>
-          <p:cNvPr id="22" name="Rounded Rectangle 21"/>
+          <p:cNvPr id="42" name="Rounded Rectangle 41"/>
           <p:cNvSpPr/>
           <p:nvPr/>
         </p:nvSpPr>
         <p:spPr>
           <a:xfrm>
-            <a:off x="7644384" y="1920240"/>
-            <a:ext cx="1051560" cy="777240"/>
+            <a:off x="7675021" y="1920240"/>
+            <a:ext cx="903243" cy="731520"/>
           </a:xfrm>
           <a:prstGeom prst="roundRect">
             <a:avLst/>
@@ -4657,21 +4857,13 @@
           <a:bodyPr rtlCol="0" anchor="ctr" wrap="square"/>
           <a:lstStyle/>
           <a:p>
-            <a:pPr algn="ctr">
-              <a:spcBef>
-                <a:spcPts val="0"/>
-              </a:spcBef>
-              <a:spcAft>
-                <a:spcPts val="0"/>
-              </a:spcAft>
-              <a:defRPr sz="1000" b="1">
+            <a:pPr algn="ctr"/>
+            <a:r>
+              <a:rPr sz="1000">
                 <a:solidFill>
                   <a:srgbClr val="FFFFFF"/>
                 </a:solidFill>
-                <a:latin typeface="Segoe UI"/>
-              </a:defRPr>
-            </a:pPr>
-            <a:r>
+              </a:rPr>
               <a:t>Documenter</a:t>
             </a:r>
           </a:p>
@@ -4679,20 +4871,20 @@
       </p:sp>
       <p:sp>
         <p:nvSpPr>
-          <p:cNvPr id="23" name="Right Arrow 22"/>
+          <p:cNvPr id="43" name="Right Arrow 42"/>
           <p:cNvSpPr/>
           <p:nvPr/>
         </p:nvSpPr>
         <p:spPr>
           <a:xfrm>
-            <a:off x="8695944" y="2171700"/>
-            <a:ext cx="146304" cy="274320"/>
+            <a:off x="8596264" y="2171700"/>
+            <a:ext cx="118000" cy="228600"/>
           </a:xfrm>
           <a:prstGeom prst="rightArrow">
             <a:avLst/>
           </a:prstGeom>
           <a:solidFill>
-            <a:srgbClr val="666666"/>
+            <a:srgbClr val="808080"/>
           </a:solidFill>
           <a:ln>
             <a:noFill/>
@@ -4722,14 +4914,14 @@
       </p:sp>
       <p:sp>
         <p:nvSpPr>
-          <p:cNvPr id="24" name="Rounded Rectangle 23"/>
+          <p:cNvPr id="44" name="Rounded Rectangle 43"/>
           <p:cNvSpPr/>
           <p:nvPr/>
         </p:nvSpPr>
         <p:spPr>
           <a:xfrm>
-            <a:off x="8842248" y="1920240"/>
-            <a:ext cx="1051560" cy="777240"/>
+            <a:off x="8732264" y="1920240"/>
+            <a:ext cx="903243" cy="731520"/>
           </a:xfrm>
           <a:prstGeom prst="roundRect">
             <a:avLst/>
@@ -4759,21 +4951,13 @@
           <a:bodyPr rtlCol="0" anchor="ctr" wrap="square"/>
           <a:lstStyle/>
           <a:p>
-            <a:pPr algn="ctr">
-              <a:spcBef>
-                <a:spcPts val="0"/>
-              </a:spcBef>
-              <a:spcAft>
-                <a:spcPts val="0"/>
-              </a:spcAft>
-              <a:defRPr sz="1000" b="1">
+            <a:pPr algn="ctr"/>
+            <a:r>
+              <a:rPr sz="1000">
                 <a:solidFill>
                   <a:srgbClr val="FFFFFF"/>
                 </a:solidFill>
-                <a:latin typeface="Segoe UI"/>
-              </a:defRPr>
-            </a:pPr>
-            <a:r>
+              </a:rPr>
               <a:t>Builder</a:t>
             </a:r>
           </a:p>
@@ -4781,20 +4965,20 @@
       </p:sp>
       <p:sp>
         <p:nvSpPr>
-          <p:cNvPr id="25" name="Right Arrow 24"/>
+          <p:cNvPr id="45" name="Right Arrow 44"/>
           <p:cNvSpPr/>
           <p:nvPr/>
         </p:nvSpPr>
         <p:spPr>
           <a:xfrm>
-            <a:off x="9893808" y="2171700"/>
-            <a:ext cx="146304" cy="274320"/>
+            <a:off x="9653507" y="2171700"/>
+            <a:ext cx="118000" cy="228600"/>
           </a:xfrm>
           <a:prstGeom prst="rightArrow">
             <a:avLst/>
           </a:prstGeom>
           <a:solidFill>
-            <a:srgbClr val="666666"/>
+            <a:srgbClr val="808080"/>
           </a:solidFill>
           <a:ln>
             <a:noFill/>
@@ -4824,14 +5008,14 @@
       </p:sp>
       <p:sp>
         <p:nvSpPr>
-          <p:cNvPr id="26" name="Rounded Rectangle 25"/>
+          <p:cNvPr id="46" name="Rounded Rectangle 45"/>
           <p:cNvSpPr/>
           <p:nvPr/>
         </p:nvSpPr>
         <p:spPr>
           <a:xfrm>
-            <a:off x="10040112" y="1920240"/>
-            <a:ext cx="1051560" cy="777240"/>
+            <a:off x="9789507" y="1920240"/>
+            <a:ext cx="903243" cy="731520"/>
           </a:xfrm>
           <a:prstGeom prst="roundRect">
             <a:avLst/>
@@ -4861,25 +5045,22 @@
           <a:bodyPr rtlCol="0" anchor="ctr" wrap="square"/>
           <a:lstStyle/>
           <a:p>
-            <a:pPr algn="ctr">
-              <a:spcBef>
-                <a:spcPts val="0"/>
-              </a:spcBef>
-              <a:spcAft>
-                <a:spcPts val="0"/>
-              </a:spcAft>
-              <a:defRPr sz="1000" b="1">
+            <a:pPr algn="ctr"/>
+            <a:r>
+              <a:rPr sz="1000">
                 <a:solidFill>
                   <a:srgbClr val="FFFFFF"/>
                 </a:solidFill>
-                <a:latin typeface="Segoe UI"/>
-              </a:defRPr>
-            </a:pPr>
-            <a:r>
+              </a:rPr>
               <a:t>Retro-</a:t>
             </a:r>
             <a:br/>
             <a:r>
+              <a:rPr sz="1000">
+                <a:solidFill>
+                  <a:srgbClr val="FFFFFF"/>
+                </a:solidFill>
+              </a:rPr>
               <a:t>spective</a:t>
             </a:r>
           </a:p>
@@ -4887,103 +5068,103 @@
       </p:sp>
       <p:sp>
         <p:nvSpPr>
-          <p:cNvPr id="27" name="TextBox 26"/>
-          <p:cNvSpPr txBox="1"/>
-          <p:nvPr/>
-        </p:nvSpPr>
-        <p:spPr>
-          <a:xfrm>
-            <a:off x="731520" y="3200400"/>
-            <a:ext cx="8229600" cy="2286000"/>
-          </a:xfrm>
-          <a:prstGeom prst="rect">
-            <a:avLst/>
-          </a:prstGeom>
-          <a:noFill/>
-        </p:spPr>
-        <p:txBody>
-          <a:bodyPr wrap="square">
-            <a:spAutoFit/>
-          </a:bodyPr>
-          <a:lstStyle/>
-          <a:p>
-            <a:pPr>
-              <a:spcAft>
-                <a:spcPts val="600"/>
-              </a:spcAft>
-              <a:defRPr sz="1200">
-                <a:solidFill>
-                  <a:srgbClr val="333333"/>
-                </a:solidFill>
-                <a:latin typeface="Segoe UI"/>
-              </a:defRPr>
-            </a:pPr>
-            <a:r>
-              <a:t>Forward transitions are validated — you cannot skip roles</a:t>
-            </a:r>
-          </a:p>
-          <a:p>
-            <a:pPr>
-              <a:spcAft>
-                <a:spcPts val="600"/>
-              </a:spcAft>
-              <a:defRPr sz="1200">
-                <a:solidFill>
-                  <a:srgbClr val="333333"/>
-                </a:solidFill>
-                <a:latin typeface="Segoe UI"/>
-              </a:defRPr>
-            </a:pPr>
-            <a:r>
-              <a:t>Backward transitions to any prior role are always allowed</a:t>
-            </a:r>
-          </a:p>
-          <a:p>
-            <a:pPr>
-              <a:spcAft>
-                <a:spcPts val="600"/>
-              </a:spcAft>
-              <a:defRPr sz="1200">
-                <a:solidFill>
-                  <a:srgbClr val="333333"/>
-                </a:solidFill>
-                <a:latin typeface="Segoe UI"/>
-              </a:defRPr>
-            </a:pPr>
-            <a:r>
-              <a:t>Each role defines Required Outputs that must exist before moving forward</a:t>
-            </a:r>
-          </a:p>
-          <a:p>
-            <a:pPr>
-              <a:spcAft>
-                <a:spcPts val="600"/>
-              </a:spcAft>
-              <a:defRPr sz="1200">
-                <a:solidFill>
-                  <a:srgbClr val="333333"/>
-                </a:solidFill>
-                <a:latin typeface="Segoe UI"/>
-              </a:defRPr>
-            </a:pPr>
-            <a:r>
-              <a:t>Role Decision Notes are required for every role (audit trail)</a:t>
-            </a:r>
-          </a:p>
-          <a:p>
-            <a:pPr>
-              <a:spcAft>
-                <a:spcPts val="600"/>
-              </a:spcAft>
-              <a:defRPr sz="1200">
-                <a:solidFill>
-                  <a:srgbClr val="333333"/>
-                </a:solidFill>
-                <a:latin typeface="Segoe UI"/>
-              </a:defRPr>
-            </a:pPr>
-            <a:r>
-              <a:t>Gates can be bypassed with explicit consent (recorded as deviations)</a:t>
+          <p:cNvPr id="47" name="Right Arrow 46"/>
+          <p:cNvSpPr/>
+          <p:nvPr/>
+        </p:nvSpPr>
+        <p:spPr>
+          <a:xfrm>
+            <a:off x="10710750" y="2171700"/>
+            <a:ext cx="118000" cy="228600"/>
+          </a:xfrm>
+          <a:prstGeom prst="rightArrow">
+            <a:avLst/>
+          </a:prstGeom>
+          <a:solidFill>
+            <a:srgbClr val="808080"/>
+          </a:solidFill>
+          <a:ln>
+            <a:noFill/>
+          </a:ln>
+        </p:spPr>
+        <p:style>
+          <a:lnRef idx="1">
+            <a:schemeClr val="accent1"/>
+          </a:lnRef>
+          <a:fillRef idx="3">
+            <a:schemeClr val="accent1"/>
+          </a:fillRef>
+          <a:effectRef idx="2">
+            <a:schemeClr val="accent1"/>
+          </a:effectRef>
+          <a:fontRef idx="minor">
+            <a:schemeClr val="lt1"/>
+          </a:fontRef>
+        </p:style>
+        <p:txBody>
+          <a:bodyPr rtlCol="0" anchor="ctr"/>
+          <a:lstStyle/>
+          <a:p>
+            <a:pPr algn="ctr"/>
+          </a:p>
+        </p:txBody>
+      </p:sp>
+      <p:sp>
+        <p:nvSpPr>
+          <p:cNvPr id="48" name="Rounded Rectangle 47"/>
+          <p:cNvSpPr/>
+          <p:nvPr/>
+        </p:nvSpPr>
+        <p:spPr>
+          <a:xfrm>
+            <a:off x="10846750" y="1920240"/>
+            <a:ext cx="903243" cy="731520"/>
+          </a:xfrm>
+          <a:prstGeom prst="roundRect">
+            <a:avLst/>
+          </a:prstGeom>
+          <a:solidFill>
+            <a:srgbClr val="008080"/>
+          </a:solidFill>
+          <a:ln>
+            <a:noFill/>
+          </a:ln>
+        </p:spPr>
+        <p:style>
+          <a:lnRef idx="1">
+            <a:schemeClr val="accent1"/>
+          </a:lnRef>
+          <a:fillRef idx="3">
+            <a:schemeClr val="accent1"/>
+          </a:fillRef>
+          <a:effectRef idx="2">
+            <a:schemeClr val="accent1"/>
+          </a:effectRef>
+          <a:fontRef idx="minor">
+            <a:schemeClr val="lt1"/>
+          </a:fontRef>
+        </p:style>
+        <p:txBody>
+          <a:bodyPr rtlCol="0" anchor="ctr" wrap="square"/>
+          <a:lstStyle/>
+          <a:p>
+            <a:pPr algn="ctr"/>
+            <a:r>
+              <a:rPr sz="1000">
+                <a:solidFill>
+                  <a:srgbClr val="FFFFFF"/>
+                </a:solidFill>
+              </a:rPr>
+              <a:t>POA</a:t>
+            </a:r>
+            <a:br/>
+            <a:r>
+              <a:rPr sz="1000">
+                <a:solidFill>
+                  <a:srgbClr val="FFFFFF"/>
+                </a:solidFill>
+              </a:rPr>
+              <a:t>Closure</a:t>
             </a:r>
           </a:p>
         </p:txBody>
@@ -6220,210 +6401,86 @@
           </a:bodyPr>
           <a:lstStyle/>
           <a:p>
-            <a:pPr>
-              <a:spcAft>
-                <a:spcPts val="200"/>
-              </a:spcAft>
-              <a:defRPr sz="1100">
-                <a:solidFill>
-                  <a:srgbClr val="333333"/>
-                </a:solidFill>
-                <a:latin typeface="Segoe UI"/>
-              </a:defRPr>
-            </a:pPr>
-            <a:r>
-              <a:t>WorkItems/GCP-0045/</a:t>
-            </a:r>
-          </a:p>
-          <a:p>
-            <a:pPr>
-              <a:spcAft>
-                <a:spcPts val="200"/>
-              </a:spcAft>
-              <a:defRPr sz="1100">
-                <a:solidFill>
-                  <a:srgbClr val="333333"/>
-                </a:solidFill>
-                <a:latin typeface="Segoe UI"/>
-              </a:defRPr>
-            </a:pPr>
-            <a:r>
-              <a:t>├── GCP-0045-User-Story.md</a:t>
-            </a:r>
-          </a:p>
-          <a:p>
-            <a:pPr>
-              <a:spcAft>
-                <a:spcPts val="200"/>
-              </a:spcAft>
-              <a:defRPr sz="1100">
-                <a:solidFill>
-                  <a:srgbClr val="333333"/>
-                </a:solidFill>
-                <a:latin typeface="Segoe UI"/>
-              </a:defRPr>
-            </a:pPr>
-            <a:r>
+            <a:r>
+              <a:rPr lang="en-US"/>
+              <a:t>WorkItems/GCP-0047/</a:t>
+            </a:r>
+          </a:p>
+          <a:p>
+            <a:r>
+              <a:rPr lang="en-US"/>
+              <a:t>├── GCP-0047-User-Story.md</a:t>
+            </a:r>
+          </a:p>
+          <a:p>
+            <a:r>
+              <a:rPr lang="en-US"/>
+              <a:t>├── GCP-0047-closure.md</a:t>
+            </a:r>
+          </a:p>
+          <a:p>
+            <a:r>
+              <a:rPr lang="en-US"/>
               <a:t>├── state.json</a:t>
             </a:r>
           </a:p>
           <a:p>
-            <a:pPr>
-              <a:spcAft>
-                <a:spcPts val="200"/>
-              </a:spcAft>
-              <a:defRPr sz="1100">
-                <a:solidFill>
-                  <a:srgbClr val="333333"/>
-                </a:solidFill>
-                <a:latin typeface="Segoe UI"/>
-              </a:defRPr>
-            </a:pPr>
-            <a:r>
+            <a:r>
+              <a:rPr lang="en-US"/>
               <a:t>├── Design/</a:t>
             </a:r>
           </a:p>
           <a:p>
-            <a:pPr>
-              <a:spcAft>
-                <a:spcPts val="200"/>
-              </a:spcAft>
-              <a:defRPr sz="1100">
-                <a:solidFill>
-                  <a:srgbClr val="333333"/>
-                </a:solidFill>
-                <a:latin typeface="Segoe UI"/>
-              </a:defRPr>
-            </a:pPr>
-            <a:r>
-              <a:t>│   ├── GCP-0045-design-doc.md</a:t>
-            </a:r>
-          </a:p>
-          <a:p>
-            <a:pPr>
-              <a:spcAft>
-                <a:spcPts val="200"/>
-              </a:spcAft>
-              <a:defRPr sz="1100">
-                <a:solidFill>
-                  <a:srgbClr val="333333"/>
-                </a:solidFill>
-                <a:latin typeface="Segoe UI"/>
-              </a:defRPr>
-            </a:pPr>
-            <a:r>
-              <a:t>│   ├── GCP-0045-Review-Comments.md</a:t>
-            </a:r>
-          </a:p>
-          <a:p>
-            <a:pPr>
-              <a:spcAft>
-                <a:spcPts val="200"/>
-              </a:spcAft>
-              <a:defRPr sz="1100">
-                <a:solidFill>
-                  <a:srgbClr val="333333"/>
-                </a:solidFill>
-                <a:latin typeface="Segoe UI"/>
-              </a:defRPr>
-            </a:pPr>
-            <a:r>
-              <a:t>│   ├── GCP-0045-Test-Cases.md</a:t>
-            </a:r>
-          </a:p>
-          <a:p>
-            <a:pPr>
-              <a:spcAft>
-                <a:spcPts val="200"/>
-              </a:spcAft>
-              <a:defRPr sz="1100">
-                <a:solidFill>
-                  <a:srgbClr val="333333"/>
-                </a:solidFill>
-                <a:latin typeface="Segoe UI"/>
-              </a:defRPr>
-            </a:pPr>
-            <a:r>
-              <a:t>│   └── GCP-0045-Capability-Impact.md</a:t>
-            </a:r>
-          </a:p>
-          <a:p>
-            <a:pPr>
-              <a:spcAft>
-                <a:spcPts val="200"/>
-              </a:spcAft>
-              <a:defRPr sz="1100">
-                <a:solidFill>
-                  <a:srgbClr val="333333"/>
-                </a:solidFill>
-                <a:latin typeface="Segoe UI"/>
-              </a:defRPr>
-            </a:pPr>
-            <a:r>
+            <a:r>
+              <a:rPr lang="en-US"/>
+              <a:t>│   ├── GCP-0047-design-doc.md</a:t>
+            </a:r>
+          </a:p>
+          <a:p>
+            <a:r>
+              <a:rPr lang="en-US"/>
+              <a:t>│   ├── GCP-0047-Review-Comments.md</a:t>
+            </a:r>
+          </a:p>
+          <a:p>
+            <a:r>
+              <a:rPr lang="en-US"/>
+              <a:t>│   ├── GCP-0047-Test-Cases.md</a:t>
+            </a:r>
+          </a:p>
+          <a:p>
+            <a:r>
+              <a:rPr lang="en-US"/>
+              <a:t>│   └── GCP-0047-Capability-Impact.md</a:t>
+            </a:r>
+          </a:p>
+          <a:p>
+            <a:r>
+              <a:rPr lang="en-US"/>
               <a:t>└── RoleDecisionNotes/</a:t>
             </a:r>
           </a:p>
           <a:p>
-            <a:pPr>
-              <a:spcAft>
-                <a:spcPts val="200"/>
-              </a:spcAft>
-              <a:defRPr sz="1100">
-                <a:solidFill>
-                  <a:srgbClr val="333333"/>
-                </a:solidFill>
-                <a:latin typeface="Segoe UI"/>
-              </a:defRPr>
-            </a:pPr>
-            <a:r>
-              <a:t>    ├── GCP-0045-project-owner-assistant.md</a:t>
-            </a:r>
-          </a:p>
-          <a:p>
-            <a:pPr>
-              <a:spcAft>
-                <a:spcPts val="200"/>
-              </a:spcAft>
-              <a:defRPr sz="1100">
-                <a:solidFill>
-                  <a:srgbClr val="333333"/>
-                </a:solidFill>
-                <a:latin typeface="Segoe UI"/>
-              </a:defRPr>
-            </a:pPr>
-            <a:r>
-              <a:t>    ├── GCP-0045-program-manager.md</a:t>
-            </a:r>
-          </a:p>
-          <a:p>
-            <a:pPr>
-              <a:spcAft>
-                <a:spcPts val="200"/>
-              </a:spcAft>
-              <a:defRPr sz="1100">
-                <a:solidFill>
-                  <a:srgbClr val="333333"/>
-                </a:solidFill>
-                <a:latin typeface="Segoe UI"/>
-              </a:defRPr>
-            </a:pPr>
-            <a:r>
-              <a:t>    ├── GCP-0045-quality-assurance.md</a:t>
-            </a:r>
-          </a:p>
-          <a:p>
-            <a:pPr>
-              <a:spcAft>
-                <a:spcPts val="200"/>
-              </a:spcAft>
-              <a:defRPr sz="1100">
-                <a:solidFill>
-                  <a:srgbClr val="333333"/>
-                </a:solidFill>
-                <a:latin typeface="Segoe UI"/>
-              </a:defRPr>
-            </a:pPr>
-            <a:r>
+            <a:r>
+              <a:rPr lang="en-US"/>
+              <a:t>    ├── GCP-0047-project-owner-assistant.md</a:t>
+            </a:r>
+          </a:p>
+          <a:p>
+            <a:r>
+              <a:rPr lang="en-US"/>
+              <a:t>    ├── GCP-0047-program-manager.md</a:t>
+            </a:r>
+          </a:p>
+          <a:p>
+            <a:r>
+              <a:rPr lang="en-US"/>
+              <a:t>    ├── GCP-0047-quality-assurance.md</a:t>
+            </a:r>
+          </a:p>
+          <a:p>
+            <a:r>
+              <a:rPr lang="en-US"/>
               <a:t>    └── ... (one per role visited)</a:t>
             </a:r>
           </a:p>

</xml_diff>